<commit_message>
Update Cereal API Presentation.pptx
</commit_message>
<xml_diff>
--- a/Cereal API Presentation.pptx
+++ b/Cereal API Presentation.pptx
@@ -211,7 +211,7 @@
           <a:p>
             <a:fld id="{10BDB2AA-294B-42DC-98F9-9CF73F773780}" type="datetimeFigureOut">
               <a:rPr lang="da-DK" smtClean="0"/>
-              <a:t>07-05-2026</a:t>
+              <a:t>08-05-2026</a:t>
             </a:fld>
             <a:endParaRPr lang="da-DK"/>
           </a:p>
@@ -2786,7 +2786,7 @@
           <a:p>
             <a:fld id="{1B0CF485-389C-4868-9333-BAFB2426007E}" type="datetimeFigureOut">
               <a:rPr lang="da-DK" smtClean="0"/>
-              <a:t>07-05-2026</a:t>
+              <a:t>08-05-2026</a:t>
             </a:fld>
             <a:endParaRPr lang="da-DK"/>
           </a:p>
@@ -3037,7 +3037,7 @@
           <a:p>
             <a:fld id="{1B0CF485-389C-4868-9333-BAFB2426007E}" type="datetimeFigureOut">
               <a:rPr lang="da-DK" smtClean="0"/>
-              <a:t>07-05-2026</a:t>
+              <a:t>08-05-2026</a:t>
             </a:fld>
             <a:endParaRPr lang="da-DK"/>
           </a:p>
@@ -3351,7 +3351,7 @@
           <a:p>
             <a:fld id="{1B0CF485-389C-4868-9333-BAFB2426007E}" type="datetimeFigureOut">
               <a:rPr lang="da-DK" smtClean="0"/>
-              <a:t>07-05-2026</a:t>
+              <a:t>08-05-2026</a:t>
             </a:fld>
             <a:endParaRPr lang="da-DK"/>
           </a:p>
@@ -3692,7 +3692,7 @@
           <a:p>
             <a:fld id="{1B0CF485-389C-4868-9333-BAFB2426007E}" type="datetimeFigureOut">
               <a:rPr lang="da-DK" smtClean="0"/>
-              <a:t>07-05-2026</a:t>
+              <a:t>08-05-2026</a:t>
             </a:fld>
             <a:endParaRPr lang="da-DK"/>
           </a:p>
@@ -4006,7 +4006,7 @@
           <a:p>
             <a:fld id="{1B0CF485-389C-4868-9333-BAFB2426007E}" type="datetimeFigureOut">
               <a:rPr lang="da-DK" smtClean="0"/>
-              <a:t>07-05-2026</a:t>
+              <a:t>08-05-2026</a:t>
             </a:fld>
             <a:endParaRPr lang="da-DK"/>
           </a:p>
@@ -4399,7 +4399,7 @@
           <a:p>
             <a:fld id="{1B0CF485-389C-4868-9333-BAFB2426007E}" type="datetimeFigureOut">
               <a:rPr lang="da-DK" smtClean="0"/>
-              <a:t>07-05-2026</a:t>
+              <a:t>08-05-2026</a:t>
             </a:fld>
             <a:endParaRPr lang="da-DK"/>
           </a:p>
@@ -4569,7 +4569,7 @@
           <a:p>
             <a:fld id="{1B0CF485-389C-4868-9333-BAFB2426007E}" type="datetimeFigureOut">
               <a:rPr lang="da-DK" smtClean="0"/>
-              <a:t>07-05-2026</a:t>
+              <a:t>08-05-2026</a:t>
             </a:fld>
             <a:endParaRPr lang="da-DK"/>
           </a:p>
@@ -4749,7 +4749,7 @@
           <a:p>
             <a:fld id="{1B0CF485-389C-4868-9333-BAFB2426007E}" type="datetimeFigureOut">
               <a:rPr lang="da-DK" smtClean="0"/>
-              <a:t>07-05-2026</a:t>
+              <a:t>08-05-2026</a:t>
             </a:fld>
             <a:endParaRPr lang="da-DK"/>
           </a:p>
@@ -4925,7 +4925,7 @@
           <a:p>
             <a:fld id="{1B0CF485-389C-4868-9333-BAFB2426007E}" type="datetimeFigureOut">
               <a:rPr lang="da-DK" smtClean="0"/>
-              <a:t>07-05-2026</a:t>
+              <a:t>08-05-2026</a:t>
             </a:fld>
             <a:endParaRPr lang="da-DK"/>
           </a:p>
@@ -5172,7 +5172,7 @@
           <a:p>
             <a:fld id="{1B0CF485-389C-4868-9333-BAFB2426007E}" type="datetimeFigureOut">
               <a:rPr lang="da-DK" smtClean="0"/>
-              <a:t>07-05-2026</a:t>
+              <a:t>08-05-2026</a:t>
             </a:fld>
             <a:endParaRPr lang="da-DK"/>
           </a:p>
@@ -5404,7 +5404,7 @@
           <a:p>
             <a:fld id="{1B0CF485-389C-4868-9333-BAFB2426007E}" type="datetimeFigureOut">
               <a:rPr lang="da-DK" smtClean="0"/>
-              <a:t>07-05-2026</a:t>
+              <a:t>08-05-2026</a:t>
             </a:fld>
             <a:endParaRPr lang="da-DK"/>
           </a:p>
@@ -5778,7 +5778,7 @@
           <a:p>
             <a:fld id="{1B0CF485-389C-4868-9333-BAFB2426007E}" type="datetimeFigureOut">
               <a:rPr lang="da-DK" smtClean="0"/>
-              <a:t>07-05-2026</a:t>
+              <a:t>08-05-2026</a:t>
             </a:fld>
             <a:endParaRPr lang="da-DK"/>
           </a:p>
@@ -5901,7 +5901,7 @@
           <a:p>
             <a:fld id="{1B0CF485-389C-4868-9333-BAFB2426007E}" type="datetimeFigureOut">
               <a:rPr lang="da-DK" smtClean="0"/>
-              <a:t>07-05-2026</a:t>
+              <a:t>08-05-2026</a:t>
             </a:fld>
             <a:endParaRPr lang="da-DK"/>
           </a:p>
@@ -5996,7 +5996,7 @@
           <a:p>
             <a:fld id="{1B0CF485-389C-4868-9333-BAFB2426007E}" type="datetimeFigureOut">
               <a:rPr lang="da-DK" smtClean="0"/>
-              <a:t>07-05-2026</a:t>
+              <a:t>08-05-2026</a:t>
             </a:fld>
             <a:endParaRPr lang="da-DK"/>
           </a:p>
@@ -6251,7 +6251,7 @@
           <a:p>
             <a:fld id="{1B0CF485-389C-4868-9333-BAFB2426007E}" type="datetimeFigureOut">
               <a:rPr lang="da-DK" smtClean="0"/>
-              <a:t>07-05-2026</a:t>
+              <a:t>08-05-2026</a:t>
             </a:fld>
             <a:endParaRPr lang="da-DK"/>
           </a:p>
@@ -6514,7 +6514,7 @@
           <a:p>
             <a:fld id="{1B0CF485-389C-4868-9333-BAFB2426007E}" type="datetimeFigureOut">
               <a:rPr lang="da-DK" smtClean="0"/>
-              <a:t>07-05-2026</a:t>
+              <a:t>08-05-2026</a:t>
             </a:fld>
             <a:endParaRPr lang="da-DK"/>
           </a:p>
@@ -7257,7 +7257,7 @@
           <a:p>
             <a:fld id="{1B0CF485-389C-4868-9333-BAFB2426007E}" type="datetimeFigureOut">
               <a:rPr lang="da-DK" smtClean="0"/>
-              <a:t>07-05-2026</a:t>
+              <a:t>08-05-2026</a:t>
             </a:fld>
             <a:endParaRPr lang="da-DK"/>
           </a:p>
@@ -9806,13 +9806,13 @@
   <p:clrMapOvr>
     <a:masterClrMapping/>
   </p:clrMapOvr>
-  <mc:AlternateContent xmlns:mc="http://schemas.openxmlformats.org/markup-compatibility/2006">
-    <mc:Choice xmlns:p14="http://schemas.microsoft.com/office/powerpoint/2010/main" Requires="p14">
+  <mc:AlternateContent xmlns:mc="http://schemas.openxmlformats.org/markup-compatibility/2006" xmlns:p14="http://schemas.microsoft.com/office/powerpoint/2010/main">
+    <mc:Choice Requires="p14">
       <p:transition spd="slow" p14:dur="1400">
         <p14:ripple/>
       </p:transition>
     </mc:Choice>
-    <mc:Fallback>
+    <mc:Fallback xmlns="">
       <p:transition spd="slow">
         <p:fade/>
       </p:transition>
@@ -10200,7 +10200,7 @@
         </p:blipFill>
         <p:spPr>
           <a:xfrm>
-            <a:off x="3380486" y="1601317"/>
+            <a:off x="3380486" y="1930400"/>
             <a:ext cx="5431027" cy="3880772"/>
           </a:xfrm>
           <a:prstGeom prst="rect">
@@ -10315,7 +10315,7 @@
         </p:blipFill>
         <p:spPr>
           <a:xfrm>
-            <a:off x="3382962" y="1436052"/>
+            <a:off x="3382962" y="1538308"/>
             <a:ext cx="5426075" cy="4710092"/>
           </a:xfrm>
           <a:prstGeom prst="rect">

</xml_diff>

<commit_message>
Presentation work and removal of unused usings
</commit_message>
<xml_diff>
--- a/Cereal API Presentation.pptx
+++ b/Cereal API Presentation.pptx
@@ -5,7 +5,7 @@
     <p:sldMasterId id="2147483726" r:id="rId1"/>
   </p:sldMasterIdLst>
   <p:notesMasterIdLst>
-    <p:notesMasterId r:id="rId17"/>
+    <p:notesMasterId r:id="rId20"/>
   </p:notesMasterIdLst>
   <p:sldIdLst>
     <p:sldId id="256" r:id="rId2"/>
@@ -19,10 +19,13 @@
     <p:sldId id="266" r:id="rId10"/>
     <p:sldId id="268" r:id="rId11"/>
     <p:sldId id="269" r:id="rId12"/>
-    <p:sldId id="272" r:id="rId13"/>
-    <p:sldId id="261" r:id="rId14"/>
-    <p:sldId id="273" r:id="rId15"/>
-    <p:sldId id="264" r:id="rId16"/>
+    <p:sldId id="275" r:id="rId13"/>
+    <p:sldId id="276" r:id="rId14"/>
+    <p:sldId id="277" r:id="rId15"/>
+    <p:sldId id="272" r:id="rId16"/>
+    <p:sldId id="261" r:id="rId17"/>
+    <p:sldId id="273" r:id="rId18"/>
+    <p:sldId id="264" r:id="rId19"/>
   </p:sldIdLst>
   <p:sldSz cx="12192000" cy="6858000"/>
   <p:notesSz cx="6858000" cy="9144000"/>
@@ -631,29 +634,31 @@
           <a:p>
             <a:r>
               <a:rPr lang="da-DK" dirty="0"/>
-              <a:t>Show the database real </a:t>
+              <a:t>In View, or </a:t>
             </a:r>
             <a:r>
               <a:rPr lang="da-DK" dirty="0" err="1"/>
-              <a:t>quick</a:t>
+              <a:t>rather</a:t>
             </a:r>
             <a:r>
               <a:rPr lang="da-DK" dirty="0"/>
-              <a:t>!</a:t>
-            </a:r>
-          </a:p>
-          <a:p>
+              <a:t> Pages/</a:t>
+            </a:r>
+            <a:r>
+              <a:rPr lang="da-DK" dirty="0" err="1"/>
+              <a:t>Cereal</a:t>
+            </a:r>
             <a:r>
               <a:rPr lang="da-DK" dirty="0"/>
-              <a:t>Show the </a:t>
-            </a:r>
-            <a:r>
-              <a:rPr lang="da-DK" dirty="0" err="1"/>
-              <a:t>visual</a:t>
-            </a:r>
-            <a:r>
-              <a:rPr lang="da-DK" dirty="0"/>
-              <a:t> part!</a:t>
+              <a:t>/</a:t>
+            </a:r>
+            <a:r>
+              <a:rPr lang="da-DK" err="1"/>
+              <a:t>ListCereals</a:t>
+            </a:r>
+            <a:r>
+              <a:rPr lang="da-DK"/>
+              <a:t>.cshtml.cs</a:t>
             </a:r>
           </a:p>
         </p:txBody>
@@ -684,7 +689,7 @@
     </p:spTree>
     <p:extLst>
       <p:ext uri="{BB962C8B-B14F-4D97-AF65-F5344CB8AC3E}">
-        <p14:creationId xmlns:p14="http://schemas.microsoft.com/office/powerpoint/2010/main" val="3253625520"/>
+        <p14:creationId xmlns:p14="http://schemas.microsoft.com/office/powerpoint/2010/main" val="1850529932"/>
       </p:ext>
     </p:extLst>
   </p:cSld>
@@ -740,47 +745,7 @@
           <a:p>
             <a:r>
               <a:rPr lang="da-DK" dirty="0"/>
-              <a:t>Visual Studio -&gt; For </a:t>
-            </a:r>
-            <a:r>
-              <a:rPr lang="da-DK" dirty="0" err="1"/>
-              <a:t>another</a:t>
-            </a:r>
-            <a:r>
-              <a:rPr lang="da-DK" dirty="0"/>
-              <a:t> </a:t>
-            </a:r>
-            <a:r>
-              <a:rPr lang="da-DK" dirty="0" err="1"/>
-              <a:t>project</a:t>
-            </a:r>
-            <a:r>
-              <a:rPr lang="da-DK" dirty="0"/>
-              <a:t> like </a:t>
-            </a:r>
-            <a:r>
-              <a:rPr lang="da-DK" dirty="0" err="1"/>
-              <a:t>this</a:t>
-            </a:r>
-            <a:r>
-              <a:rPr lang="da-DK" dirty="0"/>
-              <a:t>, </a:t>
-            </a:r>
-            <a:r>
-              <a:rPr lang="da-DK" dirty="0" err="1"/>
-              <a:t>want</a:t>
-            </a:r>
-            <a:r>
-              <a:rPr lang="da-DK" dirty="0"/>
-              <a:t> to </a:t>
-            </a:r>
-            <a:r>
-              <a:rPr lang="da-DK" dirty="0" err="1"/>
-              <a:t>use</a:t>
-            </a:r>
-            <a:r>
-              <a:rPr lang="da-DK" dirty="0"/>
-              <a:t> the templates but not the IDE.</a:t>
+              <a:t>In controller</a:t>
             </a:r>
           </a:p>
         </p:txBody>
@@ -803,6 +768,334 @@
             <a:fld id="{C0B6F70D-8058-48C5-BEF1-1BE4D887D4AF}" type="slidenum">
               <a:rPr lang="da-DK" smtClean="0"/>
               <a:t>13</a:t>
+            </a:fld>
+            <a:endParaRPr lang="da-DK"/>
+          </a:p>
+        </p:txBody>
+      </p:sp>
+    </p:spTree>
+    <p:extLst>
+      <p:ext uri="{BB962C8B-B14F-4D97-AF65-F5344CB8AC3E}">
+        <p14:creationId xmlns:p14="http://schemas.microsoft.com/office/powerpoint/2010/main" val="2475625166"/>
+      </p:ext>
+    </p:extLst>
+  </p:cSld>
+  <p:clrMapOvr>
+    <a:masterClrMapping/>
+  </p:clrMapOvr>
+</p:notes>
+</file>
+
+<file path=ppt/notesSlides/notesSlide12.xml><?xml version="1.0" encoding="utf-8"?>
+<p:notes xmlns:a="http://schemas.openxmlformats.org/drawingml/2006/main" xmlns:r="http://schemas.openxmlformats.org/officeDocument/2006/relationships" xmlns:p="http://schemas.openxmlformats.org/presentationml/2006/main">
+  <p:cSld>
+    <p:spTree>
+      <p:nvGrpSpPr>
+        <p:cNvPr id="1" name=""/>
+        <p:cNvGrpSpPr/>
+        <p:nvPr/>
+      </p:nvGrpSpPr>
+      <p:grpSpPr>
+        <a:xfrm>
+          <a:off x="0" y="0"/>
+          <a:ext cx="0" cy="0"/>
+          <a:chOff x="0" y="0"/>
+          <a:chExt cx="0" cy="0"/>
+        </a:xfrm>
+      </p:grpSpPr>
+      <p:sp>
+        <p:nvSpPr>
+          <p:cNvPr id="2" name="Pladsholder til slidebillede 1"/>
+          <p:cNvSpPr>
+            <a:spLocks noGrp="1" noRot="1" noChangeAspect="1"/>
+          </p:cNvSpPr>
+          <p:nvPr>
+            <p:ph type="sldImg"/>
+          </p:nvPr>
+        </p:nvSpPr>
+        <p:spPr/>
+      </p:sp>
+      <p:sp>
+        <p:nvSpPr>
+          <p:cNvPr id="3" name="Pladsholder til noter 2"/>
+          <p:cNvSpPr>
+            <a:spLocks noGrp="1"/>
+          </p:cNvSpPr>
+          <p:nvPr>
+            <p:ph type="body" idx="1"/>
+          </p:nvPr>
+        </p:nvSpPr>
+        <p:spPr/>
+        <p:txBody>
+          <a:bodyPr/>
+          <a:lstStyle/>
+          <a:p>
+            <a:r>
+              <a:rPr lang="da-DK" dirty="0"/>
+              <a:t>In </a:t>
+            </a:r>
+            <a:r>
+              <a:rPr lang="da-DK" dirty="0" err="1"/>
+              <a:t>repository</a:t>
+            </a:r>
+            <a:endParaRPr lang="da-DK" dirty="0"/>
+          </a:p>
+        </p:txBody>
+      </p:sp>
+      <p:sp>
+        <p:nvSpPr>
+          <p:cNvPr id="4" name="Pladsholder til slidenummer 3"/>
+          <p:cNvSpPr>
+            <a:spLocks noGrp="1"/>
+          </p:cNvSpPr>
+          <p:nvPr>
+            <p:ph type="sldNum" sz="quarter" idx="5"/>
+          </p:nvPr>
+        </p:nvSpPr>
+        <p:spPr/>
+        <p:txBody>
+          <a:bodyPr/>
+          <a:lstStyle/>
+          <a:p>
+            <a:fld id="{C0B6F70D-8058-48C5-BEF1-1BE4D887D4AF}" type="slidenum">
+              <a:rPr lang="da-DK" smtClean="0"/>
+              <a:t>14</a:t>
+            </a:fld>
+            <a:endParaRPr lang="da-DK"/>
+          </a:p>
+        </p:txBody>
+      </p:sp>
+    </p:spTree>
+    <p:extLst>
+      <p:ext uri="{BB962C8B-B14F-4D97-AF65-F5344CB8AC3E}">
+        <p14:creationId xmlns:p14="http://schemas.microsoft.com/office/powerpoint/2010/main" val="2705428961"/>
+      </p:ext>
+    </p:extLst>
+  </p:cSld>
+  <p:clrMapOvr>
+    <a:masterClrMapping/>
+  </p:clrMapOvr>
+</p:notes>
+</file>
+
+<file path=ppt/notesSlides/notesSlide13.xml><?xml version="1.0" encoding="utf-8"?>
+<p:notes xmlns:a="http://schemas.openxmlformats.org/drawingml/2006/main" xmlns:r="http://schemas.openxmlformats.org/officeDocument/2006/relationships" xmlns:p="http://schemas.openxmlformats.org/presentationml/2006/main">
+  <p:cSld>
+    <p:spTree>
+      <p:nvGrpSpPr>
+        <p:cNvPr id="1" name=""/>
+        <p:cNvGrpSpPr/>
+        <p:nvPr/>
+      </p:nvGrpSpPr>
+      <p:grpSpPr>
+        <a:xfrm>
+          <a:off x="0" y="0"/>
+          <a:ext cx="0" cy="0"/>
+          <a:chOff x="0" y="0"/>
+          <a:chExt cx="0" cy="0"/>
+        </a:xfrm>
+      </p:grpSpPr>
+      <p:sp>
+        <p:nvSpPr>
+          <p:cNvPr id="2" name="Pladsholder til slidebillede 1"/>
+          <p:cNvSpPr>
+            <a:spLocks noGrp="1" noRot="1" noChangeAspect="1"/>
+          </p:cNvSpPr>
+          <p:nvPr>
+            <p:ph type="sldImg"/>
+          </p:nvPr>
+        </p:nvSpPr>
+        <p:spPr/>
+      </p:sp>
+      <p:sp>
+        <p:nvSpPr>
+          <p:cNvPr id="3" name="Pladsholder til noter 2"/>
+          <p:cNvSpPr>
+            <a:spLocks noGrp="1"/>
+          </p:cNvSpPr>
+          <p:nvPr>
+            <p:ph type="body" idx="1"/>
+          </p:nvPr>
+        </p:nvSpPr>
+        <p:spPr/>
+        <p:txBody>
+          <a:bodyPr/>
+          <a:lstStyle/>
+          <a:p>
+            <a:r>
+              <a:rPr lang="da-DK" dirty="0"/>
+              <a:t>Show the database real </a:t>
+            </a:r>
+            <a:r>
+              <a:rPr lang="da-DK" dirty="0" err="1"/>
+              <a:t>quick</a:t>
+            </a:r>
+            <a:r>
+              <a:rPr lang="da-DK" dirty="0"/>
+              <a:t>!</a:t>
+            </a:r>
+          </a:p>
+          <a:p>
+            <a:r>
+              <a:rPr lang="da-DK" dirty="0"/>
+              <a:t>Show the </a:t>
+            </a:r>
+            <a:r>
+              <a:rPr lang="da-DK" dirty="0" err="1"/>
+              <a:t>visual</a:t>
+            </a:r>
+            <a:r>
+              <a:rPr lang="da-DK" dirty="0"/>
+              <a:t> part!</a:t>
+            </a:r>
+          </a:p>
+        </p:txBody>
+      </p:sp>
+      <p:sp>
+        <p:nvSpPr>
+          <p:cNvPr id="4" name="Pladsholder til slidenummer 3"/>
+          <p:cNvSpPr>
+            <a:spLocks noGrp="1"/>
+          </p:cNvSpPr>
+          <p:nvPr>
+            <p:ph type="sldNum" sz="quarter" idx="5"/>
+          </p:nvPr>
+        </p:nvSpPr>
+        <p:spPr/>
+        <p:txBody>
+          <a:bodyPr/>
+          <a:lstStyle/>
+          <a:p>
+            <a:fld id="{C0B6F70D-8058-48C5-BEF1-1BE4D887D4AF}" type="slidenum">
+              <a:rPr lang="da-DK" smtClean="0"/>
+              <a:t>15</a:t>
+            </a:fld>
+            <a:endParaRPr lang="da-DK"/>
+          </a:p>
+        </p:txBody>
+      </p:sp>
+    </p:spTree>
+    <p:extLst>
+      <p:ext uri="{BB962C8B-B14F-4D97-AF65-F5344CB8AC3E}">
+        <p14:creationId xmlns:p14="http://schemas.microsoft.com/office/powerpoint/2010/main" val="3253625520"/>
+      </p:ext>
+    </p:extLst>
+  </p:cSld>
+  <p:clrMapOvr>
+    <a:masterClrMapping/>
+  </p:clrMapOvr>
+</p:notes>
+</file>
+
+<file path=ppt/notesSlides/notesSlide14.xml><?xml version="1.0" encoding="utf-8"?>
+<p:notes xmlns:a="http://schemas.openxmlformats.org/drawingml/2006/main" xmlns:r="http://schemas.openxmlformats.org/officeDocument/2006/relationships" xmlns:p="http://schemas.openxmlformats.org/presentationml/2006/main">
+  <p:cSld>
+    <p:spTree>
+      <p:nvGrpSpPr>
+        <p:cNvPr id="1" name=""/>
+        <p:cNvGrpSpPr/>
+        <p:nvPr/>
+      </p:nvGrpSpPr>
+      <p:grpSpPr>
+        <a:xfrm>
+          <a:off x="0" y="0"/>
+          <a:ext cx="0" cy="0"/>
+          <a:chOff x="0" y="0"/>
+          <a:chExt cx="0" cy="0"/>
+        </a:xfrm>
+      </p:grpSpPr>
+      <p:sp>
+        <p:nvSpPr>
+          <p:cNvPr id="2" name="Pladsholder til slidebillede 1"/>
+          <p:cNvSpPr>
+            <a:spLocks noGrp="1" noRot="1" noChangeAspect="1"/>
+          </p:cNvSpPr>
+          <p:nvPr>
+            <p:ph type="sldImg"/>
+          </p:nvPr>
+        </p:nvSpPr>
+        <p:spPr/>
+      </p:sp>
+      <p:sp>
+        <p:nvSpPr>
+          <p:cNvPr id="3" name="Pladsholder til noter 2"/>
+          <p:cNvSpPr>
+            <a:spLocks noGrp="1"/>
+          </p:cNvSpPr>
+          <p:nvPr>
+            <p:ph type="body" idx="1"/>
+          </p:nvPr>
+        </p:nvSpPr>
+        <p:spPr/>
+        <p:txBody>
+          <a:bodyPr/>
+          <a:lstStyle/>
+          <a:p>
+            <a:r>
+              <a:rPr lang="da-DK" dirty="0"/>
+              <a:t>Visual Studio -&gt; For </a:t>
+            </a:r>
+            <a:r>
+              <a:rPr lang="da-DK" dirty="0" err="1"/>
+              <a:t>another</a:t>
+            </a:r>
+            <a:r>
+              <a:rPr lang="da-DK" dirty="0"/>
+              <a:t> </a:t>
+            </a:r>
+            <a:r>
+              <a:rPr lang="da-DK" dirty="0" err="1"/>
+              <a:t>project</a:t>
+            </a:r>
+            <a:r>
+              <a:rPr lang="da-DK" dirty="0"/>
+              <a:t> like </a:t>
+            </a:r>
+            <a:r>
+              <a:rPr lang="da-DK" dirty="0" err="1"/>
+              <a:t>this</a:t>
+            </a:r>
+            <a:r>
+              <a:rPr lang="da-DK" dirty="0"/>
+              <a:t>, </a:t>
+            </a:r>
+            <a:r>
+              <a:rPr lang="da-DK" dirty="0" err="1"/>
+              <a:t>want</a:t>
+            </a:r>
+            <a:r>
+              <a:rPr lang="da-DK" dirty="0"/>
+              <a:t> to </a:t>
+            </a:r>
+            <a:r>
+              <a:rPr lang="da-DK" dirty="0" err="1"/>
+              <a:t>use</a:t>
+            </a:r>
+            <a:r>
+              <a:rPr lang="da-DK" dirty="0"/>
+              <a:t> the templates but not the IDE.</a:t>
+            </a:r>
+          </a:p>
+        </p:txBody>
+      </p:sp>
+      <p:sp>
+        <p:nvSpPr>
+          <p:cNvPr id="4" name="Pladsholder til slidenummer 3"/>
+          <p:cNvSpPr>
+            <a:spLocks noGrp="1"/>
+          </p:cNvSpPr>
+          <p:nvPr>
+            <p:ph type="sldNum" sz="quarter" idx="5"/>
+          </p:nvPr>
+        </p:nvSpPr>
+        <p:spPr/>
+        <p:txBody>
+          <a:bodyPr/>
+          <a:lstStyle/>
+          <a:p>
+            <a:fld id="{C0B6F70D-8058-48C5-BEF1-1BE4D887D4AF}" type="slidenum">
+              <a:rPr lang="da-DK" smtClean="0"/>
+              <a:t>16</a:t>
             </a:fld>
             <a:endParaRPr lang="da-DK"/>
           </a:p>
@@ -821,7 +1114,7 @@
 </p:notes>
 </file>
 
-<file path=ppt/notesSlides/notesSlide12.xml><?xml version="1.0" encoding="utf-8"?>
+<file path=ppt/notesSlides/notesSlide15.xml><?xml version="1.0" encoding="utf-8"?>
 <p:notes xmlns:a="http://schemas.openxmlformats.org/drawingml/2006/main" xmlns:r="http://schemas.openxmlformats.org/officeDocument/2006/relationships" xmlns:p="http://schemas.openxmlformats.org/presentationml/2006/main">
   <p:cSld>
     <p:spTree>
@@ -1040,7 +1333,7 @@
           <a:p>
             <a:fld id="{C0B6F70D-8058-48C5-BEF1-1BE4D887D4AF}" type="slidenum">
               <a:rPr lang="da-DK" smtClean="0"/>
-              <a:t>14</a:t>
+              <a:t>17</a:t>
             </a:fld>
             <a:endParaRPr lang="da-DK"/>
           </a:p>
@@ -9197,6 +9490,393 @@
 <file path=ppt/slides/slide12.xml><?xml version="1.0" encoding="utf-8"?>
 <p:sld xmlns:a="http://schemas.openxmlformats.org/drawingml/2006/main" xmlns:r="http://schemas.openxmlformats.org/officeDocument/2006/relationships" xmlns:p="http://schemas.openxmlformats.org/presentationml/2006/main">
   <p:cSld>
+    <p:spTree>
+      <p:nvGrpSpPr>
+        <p:cNvPr id="1" name=""/>
+        <p:cNvGrpSpPr/>
+        <p:nvPr/>
+      </p:nvGrpSpPr>
+      <p:grpSpPr>
+        <a:xfrm>
+          <a:off x="0" y="0"/>
+          <a:ext cx="0" cy="0"/>
+          <a:chOff x="0" y="0"/>
+          <a:chExt cx="0" cy="0"/>
+        </a:xfrm>
+      </p:grpSpPr>
+      <p:sp>
+        <p:nvSpPr>
+          <p:cNvPr id="2" name="Titel 1">
+            <a:extLst>
+              <a:ext uri="{FF2B5EF4-FFF2-40B4-BE49-F238E27FC236}">
+                <a16:creationId xmlns:a16="http://schemas.microsoft.com/office/drawing/2014/main" id="{9C24426E-74FE-3EA8-5BD9-CA06683A7855}"/>
+              </a:ext>
+            </a:extLst>
+          </p:cNvPr>
+          <p:cNvSpPr>
+            <a:spLocks noGrp="1"/>
+          </p:cNvSpPr>
+          <p:nvPr>
+            <p:ph type="title"/>
+          </p:nvPr>
+        </p:nvSpPr>
+        <p:spPr/>
+        <p:txBody>
+          <a:bodyPr/>
+          <a:lstStyle/>
+          <a:p>
+            <a:r>
+              <a:rPr lang="en-GB" noProof="0" dirty="0"/>
+              <a:t>Frontend to backend</a:t>
+            </a:r>
+          </a:p>
+        </p:txBody>
+      </p:sp>
+      <p:sp>
+        <p:nvSpPr>
+          <p:cNvPr id="3" name="Pladsholder til indhold 2">
+            <a:extLst>
+              <a:ext uri="{FF2B5EF4-FFF2-40B4-BE49-F238E27FC236}">
+                <a16:creationId xmlns:a16="http://schemas.microsoft.com/office/drawing/2014/main" id="{C5C96C93-2D2B-AEE4-F65B-123BFCE9F0F3}"/>
+              </a:ext>
+            </a:extLst>
+          </p:cNvPr>
+          <p:cNvSpPr>
+            <a:spLocks noGrp="1"/>
+          </p:cNvSpPr>
+          <p:nvPr>
+            <p:ph sz="half" idx="1"/>
+          </p:nvPr>
+        </p:nvSpPr>
+        <p:spPr/>
+        <p:txBody>
+          <a:bodyPr/>
+          <a:lstStyle/>
+          <a:p>
+            <a:endParaRPr lang="en-GB" noProof="0" dirty="0"/>
+          </a:p>
+        </p:txBody>
+      </p:sp>
+      <p:pic>
+        <p:nvPicPr>
+          <p:cNvPr id="6" name="Pladsholder til indhold 5">
+            <a:extLst>
+              <a:ext uri="{FF2B5EF4-FFF2-40B4-BE49-F238E27FC236}">
+                <a16:creationId xmlns:a16="http://schemas.microsoft.com/office/drawing/2014/main" id="{A1FEAA65-1F40-F4E6-3091-C97617963AB8}"/>
+              </a:ext>
+            </a:extLst>
+          </p:cNvPr>
+          <p:cNvPicPr>
+            <a:picLocks noGrp="1" noChangeAspect="1"/>
+          </p:cNvPicPr>
+          <p:nvPr>
+            <p:ph sz="half" idx="2"/>
+          </p:nvPr>
+        </p:nvPicPr>
+        <p:blipFill>
+          <a:blip r:embed="rId3"/>
+          <a:stretch>
+            <a:fillRect/>
+          </a:stretch>
+        </p:blipFill>
+        <p:spPr>
+          <a:xfrm>
+            <a:off x="2235278" y="1883470"/>
+            <a:ext cx="7721443" cy="3091059"/>
+          </a:xfrm>
+          <a:prstGeom prst="rect">
+            <a:avLst/>
+          </a:prstGeom>
+        </p:spPr>
+      </p:pic>
+    </p:spTree>
+    <p:extLst>
+      <p:ext uri="{BB962C8B-B14F-4D97-AF65-F5344CB8AC3E}">
+        <p14:creationId xmlns:p14="http://schemas.microsoft.com/office/powerpoint/2010/main" val="2996021933"/>
+      </p:ext>
+    </p:extLst>
+  </p:cSld>
+  <p:clrMapOvr>
+    <a:masterClrMapping/>
+  </p:clrMapOvr>
+</p:sld>
+</file>
+
+<file path=ppt/slides/slide13.xml><?xml version="1.0" encoding="utf-8"?>
+<p:sld xmlns:a="http://schemas.openxmlformats.org/drawingml/2006/main" xmlns:r="http://schemas.openxmlformats.org/officeDocument/2006/relationships" xmlns:p="http://schemas.openxmlformats.org/presentationml/2006/main">
+  <p:cSld>
+    <p:spTree>
+      <p:nvGrpSpPr>
+        <p:cNvPr id="1" name="">
+          <a:extLst>
+            <a:ext uri="{FF2B5EF4-FFF2-40B4-BE49-F238E27FC236}">
+              <a16:creationId xmlns:a16="http://schemas.microsoft.com/office/drawing/2014/main" id="{9536D188-A859-F5DD-FA7E-49E018B7C2D7}"/>
+            </a:ext>
+          </a:extLst>
+        </p:cNvPr>
+        <p:cNvGrpSpPr/>
+        <p:nvPr/>
+      </p:nvGrpSpPr>
+      <p:grpSpPr>
+        <a:xfrm>
+          <a:off x="0" y="0"/>
+          <a:ext cx="0" cy="0"/>
+          <a:chOff x="0" y="0"/>
+          <a:chExt cx="0" cy="0"/>
+        </a:xfrm>
+      </p:grpSpPr>
+      <p:sp>
+        <p:nvSpPr>
+          <p:cNvPr id="2" name="Titel 1">
+            <a:extLst>
+              <a:ext uri="{FF2B5EF4-FFF2-40B4-BE49-F238E27FC236}">
+                <a16:creationId xmlns:a16="http://schemas.microsoft.com/office/drawing/2014/main" id="{FB67C22C-B4AD-292E-5A38-EE0A171D8D84}"/>
+              </a:ext>
+            </a:extLst>
+          </p:cNvPr>
+          <p:cNvSpPr>
+            <a:spLocks noGrp="1"/>
+          </p:cNvSpPr>
+          <p:nvPr>
+            <p:ph type="title"/>
+          </p:nvPr>
+        </p:nvSpPr>
+        <p:spPr/>
+        <p:txBody>
+          <a:bodyPr/>
+          <a:lstStyle/>
+          <a:p>
+            <a:r>
+              <a:rPr lang="en-GB" noProof="0" dirty="0"/>
+              <a:t>Frontend to backend</a:t>
+            </a:r>
+          </a:p>
+        </p:txBody>
+      </p:sp>
+      <p:sp>
+        <p:nvSpPr>
+          <p:cNvPr id="3" name="Pladsholder til indhold 2">
+            <a:extLst>
+              <a:ext uri="{FF2B5EF4-FFF2-40B4-BE49-F238E27FC236}">
+                <a16:creationId xmlns:a16="http://schemas.microsoft.com/office/drawing/2014/main" id="{3F35DF70-D594-B5D4-798E-C633AB8FE8D3}"/>
+              </a:ext>
+            </a:extLst>
+          </p:cNvPr>
+          <p:cNvSpPr>
+            <a:spLocks noGrp="1"/>
+          </p:cNvSpPr>
+          <p:nvPr>
+            <p:ph sz="half" idx="1"/>
+          </p:nvPr>
+        </p:nvSpPr>
+        <p:spPr/>
+        <p:txBody>
+          <a:bodyPr/>
+          <a:lstStyle/>
+          <a:p>
+            <a:endParaRPr lang="en-GB" noProof="0" dirty="0"/>
+          </a:p>
+        </p:txBody>
+      </p:sp>
+      <p:pic>
+        <p:nvPicPr>
+          <p:cNvPr id="8" name="Pladsholder til indhold 7">
+            <a:extLst>
+              <a:ext uri="{FF2B5EF4-FFF2-40B4-BE49-F238E27FC236}">
+                <a16:creationId xmlns:a16="http://schemas.microsoft.com/office/drawing/2014/main" id="{C6A1E9F0-B202-D8B3-6316-5E69D82F1A8D}"/>
+              </a:ext>
+            </a:extLst>
+          </p:cNvPr>
+          <p:cNvPicPr>
+            <a:picLocks noGrp="1" noChangeAspect="1"/>
+          </p:cNvPicPr>
+          <p:nvPr>
+            <p:ph sz="half" idx="2"/>
+          </p:nvPr>
+        </p:nvPicPr>
+        <p:blipFill>
+          <a:blip r:embed="rId3"/>
+          <a:stretch>
+            <a:fillRect/>
+          </a:stretch>
+        </p:blipFill>
+        <p:spPr>
+          <a:xfrm>
+            <a:off x="3408362" y="1468247"/>
+            <a:ext cx="5375275" cy="2537129"/>
+          </a:xfrm>
+          <a:prstGeom prst="rect">
+            <a:avLst/>
+          </a:prstGeom>
+        </p:spPr>
+      </p:pic>
+    </p:spTree>
+    <p:extLst>
+      <p:ext uri="{BB962C8B-B14F-4D97-AF65-F5344CB8AC3E}">
+        <p14:creationId xmlns:p14="http://schemas.microsoft.com/office/powerpoint/2010/main" val="3184688641"/>
+      </p:ext>
+    </p:extLst>
+  </p:cSld>
+  <p:clrMapOvr>
+    <a:masterClrMapping/>
+  </p:clrMapOvr>
+</p:sld>
+</file>
+
+<file path=ppt/slides/slide14.xml><?xml version="1.0" encoding="utf-8"?>
+<p:sld xmlns:a="http://schemas.openxmlformats.org/drawingml/2006/main" xmlns:r="http://schemas.openxmlformats.org/officeDocument/2006/relationships" xmlns:p="http://schemas.openxmlformats.org/presentationml/2006/main">
+  <p:cSld>
+    <p:spTree>
+      <p:nvGrpSpPr>
+        <p:cNvPr id="1" name="">
+          <a:extLst>
+            <a:ext uri="{FF2B5EF4-FFF2-40B4-BE49-F238E27FC236}">
+              <a16:creationId xmlns:a16="http://schemas.microsoft.com/office/drawing/2014/main" id="{0C20CFA4-9112-7C39-11DD-A7CD0F0E4103}"/>
+            </a:ext>
+          </a:extLst>
+        </p:cNvPr>
+        <p:cNvGrpSpPr/>
+        <p:nvPr/>
+      </p:nvGrpSpPr>
+      <p:grpSpPr>
+        <a:xfrm>
+          <a:off x="0" y="0"/>
+          <a:ext cx="0" cy="0"/>
+          <a:chOff x="0" y="0"/>
+          <a:chExt cx="0" cy="0"/>
+        </a:xfrm>
+      </p:grpSpPr>
+      <p:sp>
+        <p:nvSpPr>
+          <p:cNvPr id="2" name="Titel 1">
+            <a:extLst>
+              <a:ext uri="{FF2B5EF4-FFF2-40B4-BE49-F238E27FC236}">
+                <a16:creationId xmlns:a16="http://schemas.microsoft.com/office/drawing/2014/main" id="{5275C1B4-EE58-511A-22F6-0C99797F5C12}"/>
+              </a:ext>
+            </a:extLst>
+          </p:cNvPr>
+          <p:cNvSpPr>
+            <a:spLocks noGrp="1"/>
+          </p:cNvSpPr>
+          <p:nvPr>
+            <p:ph type="title"/>
+          </p:nvPr>
+        </p:nvSpPr>
+        <p:spPr/>
+        <p:txBody>
+          <a:bodyPr/>
+          <a:lstStyle/>
+          <a:p>
+            <a:r>
+              <a:rPr lang="en-GB" noProof="0" dirty="0"/>
+              <a:t>Frontend to backend</a:t>
+            </a:r>
+          </a:p>
+        </p:txBody>
+      </p:sp>
+      <p:sp>
+        <p:nvSpPr>
+          <p:cNvPr id="3" name="Pladsholder til indhold 2">
+            <a:extLst>
+              <a:ext uri="{FF2B5EF4-FFF2-40B4-BE49-F238E27FC236}">
+                <a16:creationId xmlns:a16="http://schemas.microsoft.com/office/drawing/2014/main" id="{67DD4A1A-92BD-5701-A74B-8EA4AFD64B79}"/>
+              </a:ext>
+            </a:extLst>
+          </p:cNvPr>
+          <p:cNvSpPr>
+            <a:spLocks noGrp="1"/>
+          </p:cNvSpPr>
+          <p:nvPr>
+            <p:ph sz="half" idx="1"/>
+          </p:nvPr>
+        </p:nvSpPr>
+        <p:spPr/>
+        <p:txBody>
+          <a:bodyPr/>
+          <a:lstStyle/>
+          <a:p>
+            <a:endParaRPr lang="en-GB" noProof="0" dirty="0"/>
+          </a:p>
+        </p:txBody>
+      </p:sp>
+      <p:pic>
+        <p:nvPicPr>
+          <p:cNvPr id="8" name="Pladsholder til indhold 7">
+            <a:extLst>
+              <a:ext uri="{FF2B5EF4-FFF2-40B4-BE49-F238E27FC236}">
+                <a16:creationId xmlns:a16="http://schemas.microsoft.com/office/drawing/2014/main" id="{62CBD62F-636C-4660-28FF-8CBD3FDD4E64}"/>
+              </a:ext>
+            </a:extLst>
+          </p:cNvPr>
+          <p:cNvPicPr>
+            <a:picLocks noGrp="1" noChangeAspect="1"/>
+          </p:cNvPicPr>
+          <p:nvPr>
+            <p:ph sz="half" idx="2"/>
+          </p:nvPr>
+        </p:nvPicPr>
+        <p:blipFill>
+          <a:blip r:embed="rId3"/>
+          <a:stretch>
+            <a:fillRect/>
+          </a:stretch>
+        </p:blipFill>
+        <p:spPr>
+          <a:xfrm>
+            <a:off x="3408362" y="1468247"/>
+            <a:ext cx="5375275" cy="2537129"/>
+          </a:xfrm>
+          <a:prstGeom prst="rect">
+            <a:avLst/>
+          </a:prstGeom>
+        </p:spPr>
+      </p:pic>
+      <p:pic>
+        <p:nvPicPr>
+          <p:cNvPr id="10" name="Billede 9">
+            <a:extLst>
+              <a:ext uri="{FF2B5EF4-FFF2-40B4-BE49-F238E27FC236}">
+                <a16:creationId xmlns:a16="http://schemas.microsoft.com/office/drawing/2014/main" id="{32CE8D94-7B8F-9563-4FCD-9E4E6A697D6B}"/>
+              </a:ext>
+            </a:extLst>
+          </p:cNvPr>
+          <p:cNvPicPr>
+            <a:picLocks noChangeAspect="1"/>
+          </p:cNvPicPr>
+          <p:nvPr/>
+        </p:nvPicPr>
+        <p:blipFill>
+          <a:blip r:embed="rId4"/>
+          <a:stretch>
+            <a:fillRect/>
+          </a:stretch>
+        </p:blipFill>
+        <p:spPr>
+          <a:xfrm>
+            <a:off x="3459022" y="4091405"/>
+            <a:ext cx="5273956" cy="2319044"/>
+          </a:xfrm>
+          <a:prstGeom prst="rect">
+            <a:avLst/>
+          </a:prstGeom>
+        </p:spPr>
+      </p:pic>
+    </p:spTree>
+    <p:extLst>
+      <p:ext uri="{BB962C8B-B14F-4D97-AF65-F5344CB8AC3E}">
+        <p14:creationId xmlns:p14="http://schemas.microsoft.com/office/powerpoint/2010/main" val="3873237604"/>
+      </p:ext>
+    </p:extLst>
+  </p:cSld>
+  <p:clrMapOvr>
+    <a:masterClrMapping/>
+  </p:clrMapOvr>
+</p:sld>
+</file>
+
+<file path=ppt/slides/slide15.xml><?xml version="1.0" encoding="utf-8"?>
+<p:sld xmlns:a="http://schemas.openxmlformats.org/drawingml/2006/main" xmlns:r="http://schemas.openxmlformats.org/officeDocument/2006/relationships" xmlns:p="http://schemas.openxmlformats.org/presentationml/2006/main">
+  <p:cSld>
     <p:bg>
       <p:bgPr>
         <a:solidFill>
@@ -9241,7 +9921,7 @@
           <a:lstStyle/>
           <a:p>
             <a:r>
-              <a:rPr lang="da-DK" dirty="0"/>
+              <a:rPr lang="en-GB" noProof="0" dirty="0"/>
               <a:t>Demo</a:t>
             </a:r>
           </a:p>
@@ -9269,7 +9949,7 @@
           <a:lstStyle/>
           <a:p>
             <a:r>
-              <a:rPr lang="ja-JP" altLang="da-DK" dirty="0">
+              <a:rPr lang="en-GB" noProof="0" dirty="0" err="1">
                 <a:solidFill>
                   <a:schemeClr val="bg1">
                     <a:lumMod val="95000"/>
@@ -9278,7 +9958,7 @@
               </a:rPr>
               <a:t>デモンストレーション</a:t>
             </a:r>
-            <a:endParaRPr lang="da-DK" dirty="0">
+            <a:endParaRPr lang="en-GB" noProof="0" dirty="0">
               <a:solidFill>
                 <a:schemeClr val="bg1">
                   <a:lumMod val="95000"/>
@@ -9301,7 +9981,7 @@
 </p:sld>
 </file>
 
-<file path=ppt/slides/slide13.xml><?xml version="1.0" encoding="utf-8"?>
+<file path=ppt/slides/slide16.xml><?xml version="1.0" encoding="utf-8"?>
 <p:sld xmlns:a="http://schemas.openxmlformats.org/drawingml/2006/main" xmlns:r="http://schemas.openxmlformats.org/officeDocument/2006/relationships" xmlns:p="http://schemas.openxmlformats.org/presentationml/2006/main">
   <p:cSld>
     <p:spTree>
@@ -9378,7 +10058,7 @@
             </a:r>
           </a:p>
           <a:p>
-            <a:endParaRPr lang="en-GB" dirty="0"/>
+            <a:endParaRPr lang="en-GB" noProof="0" dirty="0"/>
           </a:p>
           <a:p>
             <a:r>
@@ -9426,7 +10106,7 @@
 </p:sld>
 </file>
 
-<file path=ppt/slides/slide14.xml><?xml version="1.0" encoding="utf-8"?>
+<file path=ppt/slides/slide17.xml><?xml version="1.0" encoding="utf-8"?>
 <p:sld xmlns:a="http://schemas.openxmlformats.org/drawingml/2006/main" xmlns:r="http://schemas.openxmlformats.org/officeDocument/2006/relationships" xmlns:p="http://schemas.openxmlformats.org/presentationml/2006/main">
   <p:cSld>
     <p:spTree>
@@ -9504,7 +10184,7 @@
             </a:r>
           </a:p>
           <a:p>
-            <a:endParaRPr lang="en-GB" dirty="0"/>
+            <a:endParaRPr lang="en-GB" noProof="0" dirty="0"/>
           </a:p>
           <a:p>
             <a:r>
@@ -9560,7 +10240,7 @@
 </p:sld>
 </file>
 
-<file path=ppt/slides/slide15.xml><?xml version="1.0" encoding="utf-8"?>
+<file path=ppt/slides/slide18.xml><?xml version="1.0" encoding="utf-8"?>
 <p:sld xmlns:a="http://schemas.openxmlformats.org/drawingml/2006/main" xmlns:r="http://schemas.openxmlformats.org/officeDocument/2006/relationships" xmlns:p="http://schemas.openxmlformats.org/presentationml/2006/main">
   <p:cSld>
     <p:bg>
@@ -9870,10 +10550,9 @@
           <a:lstStyle/>
           <a:p>
             <a:r>
-              <a:rPr lang="en-GB" dirty="0"/>
+              <a:rPr lang="en-GB" noProof="0" dirty="0"/>
               <a:t>Frameworks &amp; Technologies</a:t>
             </a:r>
-            <a:endParaRPr lang="en-GB" noProof="0" dirty="0"/>
           </a:p>
         </p:txBody>
       </p:sp>
@@ -9899,25 +10578,25 @@
           <a:lstStyle/>
           <a:p>
             <a:r>
-              <a:rPr lang="en-GB" dirty="0"/>
+              <a:rPr lang="en-GB" noProof="0" dirty="0"/>
               <a:t>Blazor</a:t>
             </a:r>
           </a:p>
           <a:p>
-            <a:endParaRPr lang="en-GB" dirty="0"/>
-          </a:p>
-          <a:p>
-            <a:r>
-              <a:rPr lang="en-GB" dirty="0"/>
+            <a:endParaRPr lang="en-GB" noProof="0" dirty="0"/>
+          </a:p>
+          <a:p>
+            <a:r>
+              <a:rPr lang="en-GB" noProof="0" dirty="0"/>
               <a:t>SQLite</a:t>
             </a:r>
           </a:p>
           <a:p>
-            <a:endParaRPr lang="en-GB" dirty="0"/>
-          </a:p>
-          <a:p>
-            <a:r>
-              <a:rPr lang="en-GB" dirty="0"/>
+            <a:endParaRPr lang="en-GB" noProof="0" dirty="0"/>
+          </a:p>
+          <a:p>
+            <a:r>
+              <a:rPr lang="en-GB" noProof="0" dirty="0"/>
               <a:t>Visual Studio</a:t>
             </a:r>
           </a:p>

</xml_diff>